<commit_message>
modifica del footer del diario di bordo di oggi
</commit_message>
<xml_diff>
--- a/DIARIO DI BORDO/DB-2026-03-25.pptx
+++ b/DIARIO DI BORDO/DB-2026-03-25.pptx
@@ -246,7 +246,7 @@
           <a:p>
             <a:fld id="{89AC7333-F381-462D-8F6C-9383A8A44880}" type="datetime1">
               <a:rPr lang="it-IT" smtClean="0"/>
-              <a:t>24/03/2026</a:t>
+              <a:t>25/03/2026</a:t>
             </a:fld>
             <a:endParaRPr lang="it-IT"/>
           </a:p>
@@ -424,7 +424,7 @@
           <a:p>
             <a:fld id="{E777075A-2700-4CAD-9DF2-2B8DA98C2BEF}" type="datetime1">
               <a:rPr lang="it-IT" smtClean="0"/>
-              <a:t>24/03/2026</a:t>
+              <a:t>25/03/2026</a:t>
             </a:fld>
             <a:endParaRPr lang="it-IT"/>
           </a:p>
@@ -4532,7 +4532,7 @@
         </p:nvSpPr>
         <p:spPr>
           <a:xfrm>
-            <a:off x="-228600" y="9857730"/>
+            <a:off x="-228600" y="9745662"/>
             <a:ext cx="2895600" cy="365125"/>
           </a:xfrm>
         </p:spPr>
@@ -4541,7 +4541,7 @@
           <a:lstStyle/>
           <a:p>
             <a:r>
-              <a:rPr lang="it-IT" sz="2000" noProof="0" dirty="0">
+              <a:rPr lang="it-IT" sz="2000" b="1" noProof="0" dirty="0">
                 <a:solidFill>
                   <a:schemeClr val="tx1"/>
                 </a:solidFill>
@@ -4578,13 +4578,49 @@
           <a:lstStyle/>
           <a:p>
             <a:r>
-              <a:rPr lang="it-IT" sz="2000" noProof="0" dirty="0">
+              <a:rPr lang="it-IT" sz="2000" b="1" noProof="0" dirty="0">
                 <a:solidFill>
                   <a:schemeClr val="tx1"/>
                 </a:solidFill>
               </a:rPr>
-              <a:t>2/3</a:t>
-            </a:r>
+              <a:t>1/2</a:t>
+            </a:r>
+          </a:p>
+        </p:txBody>
+      </p:sp>
+      <p:sp>
+        <p:nvSpPr>
+          <p:cNvPr id="9" name="CasellaDiTesto 8">
+            <a:extLst>
+              <a:ext uri="{FF2B5EF4-FFF2-40B4-BE49-F238E27FC236}">
+                <a16:creationId xmlns:a16="http://schemas.microsoft.com/office/drawing/2014/main" id="{55E43324-1448-8D8B-51C0-6ED8B80A37F3}"/>
+              </a:ext>
+            </a:extLst>
+          </p:cNvPr>
+          <p:cNvSpPr txBox="1"/>
+          <p:nvPr/>
+        </p:nvSpPr>
+        <p:spPr>
+          <a:xfrm>
+            <a:off x="7893424" y="9745662"/>
+            <a:ext cx="9323294" cy="369332"/>
+          </a:xfrm>
+          <a:prstGeom prst="rect">
+            <a:avLst/>
+          </a:prstGeom>
+          <a:noFill/>
+        </p:spPr>
+        <p:txBody>
+          <a:bodyPr wrap="square">
+            <a:spAutoFit/>
+          </a:bodyPr>
+          <a:lstStyle/>
+          <a:p>
+            <a:r>
+              <a:rPr lang="en-AU" b="1" dirty="0"/>
+              <a:t>25/03/2026</a:t>
+            </a:r>
+            <a:endParaRPr lang="it-IT" dirty="0"/>
           </a:p>
         </p:txBody>
       </p:sp>
@@ -4846,10 +4882,10 @@
       </p:sp>
       <p:sp>
         <p:nvSpPr>
-          <p:cNvPr id="7" name="Segnaposto piè di pagina 6">
+          <p:cNvPr id="2" name="Segnaposto piè di pagina 2">
             <a:extLst>
               <a:ext uri="{FF2B5EF4-FFF2-40B4-BE49-F238E27FC236}">
-                <a16:creationId xmlns:a16="http://schemas.microsoft.com/office/drawing/2014/main" id="{DF02E8DB-094F-CE8F-B950-FD5D722ECDF6}"/>
+                <a16:creationId xmlns:a16="http://schemas.microsoft.com/office/drawing/2014/main" id="{7CB282E6-1828-2AFA-F150-9A6D5CC8BDEB}"/>
               </a:ext>
             </a:extLst>
           </p:cNvPr>
@@ -4862,7 +4898,7 @@
         </p:nvSpPr>
         <p:spPr>
           <a:xfrm>
-            <a:off x="-228600" y="9850752"/>
+            <a:off x="-228600" y="9745662"/>
             <a:ext cx="2895600" cy="365125"/>
           </a:xfrm>
         </p:spPr>
@@ -4871,23 +4907,22 @@
           <a:lstStyle/>
           <a:p>
             <a:r>
-              <a:rPr lang="it-IT" sz="2000" noProof="0" dirty="0">
+              <a:rPr lang="it-IT" sz="2000" b="1" noProof="0" dirty="0">
                 <a:solidFill>
                   <a:schemeClr val="tx1"/>
                 </a:solidFill>
               </a:rPr>
               <a:t>BugBusters</a:t>
             </a:r>
-            <a:endParaRPr lang="it-IT" sz="2000" noProof="0" dirty="0"/>
-          </a:p>
-        </p:txBody>
-      </p:sp>
-      <p:sp>
-        <p:nvSpPr>
-          <p:cNvPr id="8" name="Segnaposto numero diapositiva 7">
+          </a:p>
+        </p:txBody>
+      </p:sp>
+      <p:sp>
+        <p:nvSpPr>
+          <p:cNvPr id="11" name="Segnaposto numero diapositiva 7">
             <a:extLst>
               <a:ext uri="{FF2B5EF4-FFF2-40B4-BE49-F238E27FC236}">
-                <a16:creationId xmlns:a16="http://schemas.microsoft.com/office/drawing/2014/main" id="{C2B058F6-0A69-1532-DB2D-68DBB0CD087C}"/>
+                <a16:creationId xmlns:a16="http://schemas.microsoft.com/office/drawing/2014/main" id="{2B017665-0075-C8EB-F386-F0429BC45C59}"/>
               </a:ext>
             </a:extLst>
           </p:cNvPr>
@@ -4897,157 +4932,69 @@
           <p:nvPr>
             <p:ph type="sldNum" sz="quarter" idx="12"/>
           </p:nvPr>
-        </p:nvSpPr>
-        <p:spPr>
-          <a:xfrm>
-            <a:off x="4038600" y="9655174"/>
-            <a:ext cx="2133600" cy="365125"/>
-          </a:xfrm>
-        </p:spPr>
-        <p:txBody>
-          <a:bodyPr/>
-          <a:lstStyle/>
-          <a:p>
-            <a:fld id="{B6F15528-21DE-4FAA-801E-634DDDAF4B2B}" type="slidenum">
-              <a:rPr lang="it-IT" noProof="0" smtClean="0"/>
-              <a:pPr/>
-              <a:t>3</a:t>
-            </a:fld>
-            <a:endParaRPr lang="it-IT" noProof="0" dirty="0"/>
-          </a:p>
-        </p:txBody>
-      </p:sp>
-      <p:sp>
-        <p:nvSpPr>
-          <p:cNvPr id="10" name="Segnaposto numero diapositiva 7">
-            <a:extLst>
-              <a:ext uri="{FF2B5EF4-FFF2-40B4-BE49-F238E27FC236}">
-                <a16:creationId xmlns:a16="http://schemas.microsoft.com/office/drawing/2014/main" id="{BBD077D0-29EB-D238-3111-F71CBA6A7A20}"/>
-              </a:ext>
-            </a:extLst>
-          </p:cNvPr>
-          <p:cNvSpPr txBox="1">
-            <a:spLocks/>
-          </p:cNvSpPr>
-          <p:nvPr/>
         </p:nvSpPr>
         <p:spPr>
           <a:xfrm>
             <a:off x="17226280" y="9745662"/>
             <a:ext cx="894131" cy="365125"/>
           </a:xfrm>
-          <a:prstGeom prst="rect">
-            <a:avLst/>
-          </a:prstGeom>
         </p:spPr>
         <p:txBody>
-          <a:bodyPr vert="horz" lIns="91440" tIns="45720" rIns="91440" bIns="45720" rtlCol="0" anchor="ctr"/>
-          <a:lstStyle>
-            <a:defPPr>
-              <a:defRPr lang="en-US"/>
-            </a:defPPr>
-            <a:lvl1pPr marL="0" algn="r" defTabSz="914400" rtl="0" eaLnBrk="1" latinLnBrk="0" hangingPunct="1">
-              <a:defRPr sz="1200" kern="1200">
-                <a:solidFill>
-                  <a:schemeClr val="tx1">
-                    <a:tint val="75000"/>
-                  </a:schemeClr>
-                </a:solidFill>
-                <a:latin typeface="+mn-lt"/>
-                <a:ea typeface="+mn-ea"/>
-                <a:cs typeface="+mn-cs"/>
-              </a:defRPr>
-            </a:lvl1pPr>
-            <a:lvl2pPr marL="457200" algn="l" defTabSz="914400" rtl="0" eaLnBrk="1" latinLnBrk="0" hangingPunct="1">
-              <a:defRPr sz="1800" kern="1200">
-                <a:solidFill>
-                  <a:schemeClr val="tx1"/>
-                </a:solidFill>
-                <a:latin typeface="+mn-lt"/>
-                <a:ea typeface="+mn-ea"/>
-                <a:cs typeface="+mn-cs"/>
-              </a:defRPr>
-            </a:lvl2pPr>
-            <a:lvl3pPr marL="914400" algn="l" defTabSz="914400" rtl="0" eaLnBrk="1" latinLnBrk="0" hangingPunct="1">
-              <a:defRPr sz="1800" kern="1200">
-                <a:solidFill>
-                  <a:schemeClr val="tx1"/>
-                </a:solidFill>
-                <a:latin typeface="+mn-lt"/>
-                <a:ea typeface="+mn-ea"/>
-                <a:cs typeface="+mn-cs"/>
-              </a:defRPr>
-            </a:lvl3pPr>
-            <a:lvl4pPr marL="1371600" algn="l" defTabSz="914400" rtl="0" eaLnBrk="1" latinLnBrk="0" hangingPunct="1">
-              <a:defRPr sz="1800" kern="1200">
-                <a:solidFill>
-                  <a:schemeClr val="tx1"/>
-                </a:solidFill>
-                <a:latin typeface="+mn-lt"/>
-                <a:ea typeface="+mn-ea"/>
-                <a:cs typeface="+mn-cs"/>
-              </a:defRPr>
-            </a:lvl4pPr>
-            <a:lvl5pPr marL="1828800" algn="l" defTabSz="914400" rtl="0" eaLnBrk="1" latinLnBrk="0" hangingPunct="1">
-              <a:defRPr sz="1800" kern="1200">
-                <a:solidFill>
-                  <a:schemeClr val="tx1"/>
-                </a:solidFill>
-                <a:latin typeface="+mn-lt"/>
-                <a:ea typeface="+mn-ea"/>
-                <a:cs typeface="+mn-cs"/>
-              </a:defRPr>
-            </a:lvl5pPr>
-            <a:lvl6pPr marL="2286000" algn="l" defTabSz="914400" rtl="0" eaLnBrk="1" latinLnBrk="0" hangingPunct="1">
-              <a:defRPr sz="1800" kern="1200">
-                <a:solidFill>
-                  <a:schemeClr val="tx1"/>
-                </a:solidFill>
-                <a:latin typeface="+mn-lt"/>
-                <a:ea typeface="+mn-ea"/>
-                <a:cs typeface="+mn-cs"/>
-              </a:defRPr>
-            </a:lvl6pPr>
-            <a:lvl7pPr marL="2743200" algn="l" defTabSz="914400" rtl="0" eaLnBrk="1" latinLnBrk="0" hangingPunct="1">
-              <a:defRPr sz="1800" kern="1200">
-                <a:solidFill>
-                  <a:schemeClr val="tx1"/>
-                </a:solidFill>
-                <a:latin typeface="+mn-lt"/>
-                <a:ea typeface="+mn-ea"/>
-                <a:cs typeface="+mn-cs"/>
-              </a:defRPr>
-            </a:lvl7pPr>
-            <a:lvl8pPr marL="3200400" algn="l" defTabSz="914400" rtl="0" eaLnBrk="1" latinLnBrk="0" hangingPunct="1">
-              <a:defRPr sz="1800" kern="1200">
-                <a:solidFill>
-                  <a:schemeClr val="tx1"/>
-                </a:solidFill>
-                <a:latin typeface="+mn-lt"/>
-                <a:ea typeface="+mn-ea"/>
-                <a:cs typeface="+mn-cs"/>
-              </a:defRPr>
-            </a:lvl8pPr>
-            <a:lvl9pPr marL="3657600" algn="l" defTabSz="914400" rtl="0" eaLnBrk="1" latinLnBrk="0" hangingPunct="1">
-              <a:defRPr sz="1800" kern="1200">
-                <a:solidFill>
-                  <a:schemeClr val="tx1"/>
-                </a:solidFill>
-                <a:latin typeface="+mn-lt"/>
-                <a:ea typeface="+mn-ea"/>
-                <a:cs typeface="+mn-cs"/>
-              </a:defRPr>
-            </a:lvl9pPr>
-          </a:lstStyle>
-          <a:p>
-            <a:r>
-              <a:rPr lang="it-IT" sz="2000" noProof="0" dirty="0">
+          <a:bodyPr/>
+          <a:lstStyle/>
+          <a:p>
+            <a:r>
+              <a:rPr lang="it-IT" sz="2000" b="1" dirty="0">
                 <a:solidFill>
                   <a:schemeClr val="tx1"/>
                 </a:solidFill>
               </a:rPr>
-              <a:t>3/3</a:t>
-            </a:r>
+              <a:t>2</a:t>
+            </a:r>
+            <a:r>
+              <a:rPr lang="it-IT" sz="2000" b="1" noProof="0" dirty="0">
+                <a:solidFill>
+                  <a:schemeClr val="tx1"/>
+                </a:solidFill>
+              </a:rPr>
+              <a:t>/2</a:t>
+            </a:r>
+          </a:p>
+        </p:txBody>
+      </p:sp>
+      <p:sp>
+        <p:nvSpPr>
+          <p:cNvPr id="12" name="CasellaDiTesto 11">
+            <a:extLst>
+              <a:ext uri="{FF2B5EF4-FFF2-40B4-BE49-F238E27FC236}">
+                <a16:creationId xmlns:a16="http://schemas.microsoft.com/office/drawing/2014/main" id="{B47C7EF8-7FBE-A0E3-3579-35EA1E5BCF90}"/>
+              </a:ext>
+            </a:extLst>
+          </p:cNvPr>
+          <p:cNvSpPr txBox="1"/>
+          <p:nvPr/>
+        </p:nvSpPr>
+        <p:spPr>
+          <a:xfrm>
+            <a:off x="7893424" y="9745662"/>
+            <a:ext cx="9323294" cy="369332"/>
+          </a:xfrm>
+          <a:prstGeom prst="rect">
+            <a:avLst/>
+          </a:prstGeom>
+          <a:noFill/>
+        </p:spPr>
+        <p:txBody>
+          <a:bodyPr wrap="square">
+            <a:spAutoFit/>
+          </a:bodyPr>
+          <a:lstStyle/>
+          <a:p>
+            <a:r>
+              <a:rPr lang="en-AU" b="1" dirty="0"/>
+              <a:t>25/03/2026</a:t>
+            </a:r>
+            <a:endParaRPr lang="it-IT" dirty="0"/>
           </a:p>
         </p:txBody>
       </p:sp>

</xml_diff>

<commit_message>
Aggiunto diario di bordo della settimana scorsa
Aggiunto diario di bordo della settimana scorsa
</commit_message>
<xml_diff>
--- a/DIARIO DI BORDO/DB-2026-03-25.pptx
+++ b/DIARIO DI BORDO/DB-2026-03-25.pptx
@@ -246,7 +246,7 @@
           <a:p>
             <a:fld id="{89AC7333-F381-462D-8F6C-9383A8A44880}" type="datetime1">
               <a:rPr lang="it-IT" smtClean="0"/>
-              <a:t>24/03/2026</a:t>
+              <a:t>25/03/2026</a:t>
             </a:fld>
             <a:endParaRPr lang="it-IT"/>
           </a:p>
@@ -424,7 +424,7 @@
           <a:p>
             <a:fld id="{E777075A-2700-4CAD-9DF2-2B8DA98C2BEF}" type="datetime1">
               <a:rPr lang="it-IT" smtClean="0"/>
-              <a:t>24/03/2026</a:t>
+              <a:t>25/03/2026</a:t>
             </a:fld>
             <a:endParaRPr lang="it-IT"/>
           </a:p>
@@ -4532,7 +4532,7 @@
         </p:nvSpPr>
         <p:spPr>
           <a:xfrm>
-            <a:off x="-228600" y="9857730"/>
+            <a:off x="-228600" y="9745662"/>
             <a:ext cx="2895600" cy="365125"/>
           </a:xfrm>
         </p:spPr>
@@ -4541,7 +4541,7 @@
           <a:lstStyle/>
           <a:p>
             <a:r>
-              <a:rPr lang="it-IT" sz="2000" noProof="0" dirty="0">
+              <a:rPr lang="it-IT" sz="2000" b="1" noProof="0" dirty="0">
                 <a:solidFill>
                   <a:schemeClr val="tx1"/>
                 </a:solidFill>
@@ -4578,13 +4578,49 @@
           <a:lstStyle/>
           <a:p>
             <a:r>
-              <a:rPr lang="it-IT" sz="2000" noProof="0" dirty="0">
+              <a:rPr lang="it-IT" sz="2000" b="1" noProof="0" dirty="0">
                 <a:solidFill>
                   <a:schemeClr val="tx1"/>
                 </a:solidFill>
               </a:rPr>
-              <a:t>2/3</a:t>
-            </a:r>
+              <a:t>1/2</a:t>
+            </a:r>
+          </a:p>
+        </p:txBody>
+      </p:sp>
+      <p:sp>
+        <p:nvSpPr>
+          <p:cNvPr id="9" name="CasellaDiTesto 8">
+            <a:extLst>
+              <a:ext uri="{FF2B5EF4-FFF2-40B4-BE49-F238E27FC236}">
+                <a16:creationId xmlns:a16="http://schemas.microsoft.com/office/drawing/2014/main" id="{55E43324-1448-8D8B-51C0-6ED8B80A37F3}"/>
+              </a:ext>
+            </a:extLst>
+          </p:cNvPr>
+          <p:cNvSpPr txBox="1"/>
+          <p:nvPr/>
+        </p:nvSpPr>
+        <p:spPr>
+          <a:xfrm>
+            <a:off x="7893424" y="9745662"/>
+            <a:ext cx="9323294" cy="369332"/>
+          </a:xfrm>
+          <a:prstGeom prst="rect">
+            <a:avLst/>
+          </a:prstGeom>
+          <a:noFill/>
+        </p:spPr>
+        <p:txBody>
+          <a:bodyPr wrap="square">
+            <a:spAutoFit/>
+          </a:bodyPr>
+          <a:lstStyle/>
+          <a:p>
+            <a:r>
+              <a:rPr lang="en-AU" b="1" dirty="0"/>
+              <a:t>25/03/2026</a:t>
+            </a:r>
+            <a:endParaRPr lang="it-IT" dirty="0"/>
           </a:p>
         </p:txBody>
       </p:sp>
@@ -4846,10 +4882,10 @@
       </p:sp>
       <p:sp>
         <p:nvSpPr>
-          <p:cNvPr id="7" name="Segnaposto piè di pagina 6">
+          <p:cNvPr id="2" name="Segnaposto piè di pagina 2">
             <a:extLst>
               <a:ext uri="{FF2B5EF4-FFF2-40B4-BE49-F238E27FC236}">
-                <a16:creationId xmlns:a16="http://schemas.microsoft.com/office/drawing/2014/main" id="{DF02E8DB-094F-CE8F-B950-FD5D722ECDF6}"/>
+                <a16:creationId xmlns:a16="http://schemas.microsoft.com/office/drawing/2014/main" id="{7CB282E6-1828-2AFA-F150-9A6D5CC8BDEB}"/>
               </a:ext>
             </a:extLst>
           </p:cNvPr>
@@ -4862,7 +4898,7 @@
         </p:nvSpPr>
         <p:spPr>
           <a:xfrm>
-            <a:off x="-228600" y="9850752"/>
+            <a:off x="-228600" y="9745662"/>
             <a:ext cx="2895600" cy="365125"/>
           </a:xfrm>
         </p:spPr>
@@ -4871,23 +4907,22 @@
           <a:lstStyle/>
           <a:p>
             <a:r>
-              <a:rPr lang="it-IT" sz="2000" noProof="0" dirty="0">
+              <a:rPr lang="it-IT" sz="2000" b="1" noProof="0" dirty="0">
                 <a:solidFill>
                   <a:schemeClr val="tx1"/>
                 </a:solidFill>
               </a:rPr>
               <a:t>BugBusters</a:t>
             </a:r>
-            <a:endParaRPr lang="it-IT" sz="2000" noProof="0" dirty="0"/>
-          </a:p>
-        </p:txBody>
-      </p:sp>
-      <p:sp>
-        <p:nvSpPr>
-          <p:cNvPr id="8" name="Segnaposto numero diapositiva 7">
+          </a:p>
+        </p:txBody>
+      </p:sp>
+      <p:sp>
+        <p:nvSpPr>
+          <p:cNvPr id="11" name="Segnaposto numero diapositiva 7">
             <a:extLst>
               <a:ext uri="{FF2B5EF4-FFF2-40B4-BE49-F238E27FC236}">
-                <a16:creationId xmlns:a16="http://schemas.microsoft.com/office/drawing/2014/main" id="{C2B058F6-0A69-1532-DB2D-68DBB0CD087C}"/>
+                <a16:creationId xmlns:a16="http://schemas.microsoft.com/office/drawing/2014/main" id="{2B017665-0075-C8EB-F386-F0429BC45C59}"/>
               </a:ext>
             </a:extLst>
           </p:cNvPr>
@@ -4897,157 +4932,69 @@
           <p:nvPr>
             <p:ph type="sldNum" sz="quarter" idx="12"/>
           </p:nvPr>
-        </p:nvSpPr>
-        <p:spPr>
-          <a:xfrm>
-            <a:off x="4038600" y="9655174"/>
-            <a:ext cx="2133600" cy="365125"/>
-          </a:xfrm>
-        </p:spPr>
-        <p:txBody>
-          <a:bodyPr/>
-          <a:lstStyle/>
-          <a:p>
-            <a:fld id="{B6F15528-21DE-4FAA-801E-634DDDAF4B2B}" type="slidenum">
-              <a:rPr lang="it-IT" noProof="0" smtClean="0"/>
-              <a:pPr/>
-              <a:t>3</a:t>
-            </a:fld>
-            <a:endParaRPr lang="it-IT" noProof="0" dirty="0"/>
-          </a:p>
-        </p:txBody>
-      </p:sp>
-      <p:sp>
-        <p:nvSpPr>
-          <p:cNvPr id="10" name="Segnaposto numero diapositiva 7">
-            <a:extLst>
-              <a:ext uri="{FF2B5EF4-FFF2-40B4-BE49-F238E27FC236}">
-                <a16:creationId xmlns:a16="http://schemas.microsoft.com/office/drawing/2014/main" id="{BBD077D0-29EB-D238-3111-F71CBA6A7A20}"/>
-              </a:ext>
-            </a:extLst>
-          </p:cNvPr>
-          <p:cNvSpPr txBox="1">
-            <a:spLocks/>
-          </p:cNvSpPr>
-          <p:nvPr/>
         </p:nvSpPr>
         <p:spPr>
           <a:xfrm>
             <a:off x="17226280" y="9745662"/>
             <a:ext cx="894131" cy="365125"/>
           </a:xfrm>
-          <a:prstGeom prst="rect">
-            <a:avLst/>
-          </a:prstGeom>
         </p:spPr>
         <p:txBody>
-          <a:bodyPr vert="horz" lIns="91440" tIns="45720" rIns="91440" bIns="45720" rtlCol="0" anchor="ctr"/>
-          <a:lstStyle>
-            <a:defPPr>
-              <a:defRPr lang="en-US"/>
-            </a:defPPr>
-            <a:lvl1pPr marL="0" algn="r" defTabSz="914400" rtl="0" eaLnBrk="1" latinLnBrk="0" hangingPunct="1">
-              <a:defRPr sz="1200" kern="1200">
-                <a:solidFill>
-                  <a:schemeClr val="tx1">
-                    <a:tint val="75000"/>
-                  </a:schemeClr>
-                </a:solidFill>
-                <a:latin typeface="+mn-lt"/>
-                <a:ea typeface="+mn-ea"/>
-                <a:cs typeface="+mn-cs"/>
-              </a:defRPr>
-            </a:lvl1pPr>
-            <a:lvl2pPr marL="457200" algn="l" defTabSz="914400" rtl="0" eaLnBrk="1" latinLnBrk="0" hangingPunct="1">
-              <a:defRPr sz="1800" kern="1200">
-                <a:solidFill>
-                  <a:schemeClr val="tx1"/>
-                </a:solidFill>
-                <a:latin typeface="+mn-lt"/>
-                <a:ea typeface="+mn-ea"/>
-                <a:cs typeface="+mn-cs"/>
-              </a:defRPr>
-            </a:lvl2pPr>
-            <a:lvl3pPr marL="914400" algn="l" defTabSz="914400" rtl="0" eaLnBrk="1" latinLnBrk="0" hangingPunct="1">
-              <a:defRPr sz="1800" kern="1200">
-                <a:solidFill>
-                  <a:schemeClr val="tx1"/>
-                </a:solidFill>
-                <a:latin typeface="+mn-lt"/>
-                <a:ea typeface="+mn-ea"/>
-                <a:cs typeface="+mn-cs"/>
-              </a:defRPr>
-            </a:lvl3pPr>
-            <a:lvl4pPr marL="1371600" algn="l" defTabSz="914400" rtl="0" eaLnBrk="1" latinLnBrk="0" hangingPunct="1">
-              <a:defRPr sz="1800" kern="1200">
-                <a:solidFill>
-                  <a:schemeClr val="tx1"/>
-                </a:solidFill>
-                <a:latin typeface="+mn-lt"/>
-                <a:ea typeface="+mn-ea"/>
-                <a:cs typeface="+mn-cs"/>
-              </a:defRPr>
-            </a:lvl4pPr>
-            <a:lvl5pPr marL="1828800" algn="l" defTabSz="914400" rtl="0" eaLnBrk="1" latinLnBrk="0" hangingPunct="1">
-              <a:defRPr sz="1800" kern="1200">
-                <a:solidFill>
-                  <a:schemeClr val="tx1"/>
-                </a:solidFill>
-                <a:latin typeface="+mn-lt"/>
-                <a:ea typeface="+mn-ea"/>
-                <a:cs typeface="+mn-cs"/>
-              </a:defRPr>
-            </a:lvl5pPr>
-            <a:lvl6pPr marL="2286000" algn="l" defTabSz="914400" rtl="0" eaLnBrk="1" latinLnBrk="0" hangingPunct="1">
-              <a:defRPr sz="1800" kern="1200">
-                <a:solidFill>
-                  <a:schemeClr val="tx1"/>
-                </a:solidFill>
-                <a:latin typeface="+mn-lt"/>
-                <a:ea typeface="+mn-ea"/>
-                <a:cs typeface="+mn-cs"/>
-              </a:defRPr>
-            </a:lvl6pPr>
-            <a:lvl7pPr marL="2743200" algn="l" defTabSz="914400" rtl="0" eaLnBrk="1" latinLnBrk="0" hangingPunct="1">
-              <a:defRPr sz="1800" kern="1200">
-                <a:solidFill>
-                  <a:schemeClr val="tx1"/>
-                </a:solidFill>
-                <a:latin typeface="+mn-lt"/>
-                <a:ea typeface="+mn-ea"/>
-                <a:cs typeface="+mn-cs"/>
-              </a:defRPr>
-            </a:lvl7pPr>
-            <a:lvl8pPr marL="3200400" algn="l" defTabSz="914400" rtl="0" eaLnBrk="1" latinLnBrk="0" hangingPunct="1">
-              <a:defRPr sz="1800" kern="1200">
-                <a:solidFill>
-                  <a:schemeClr val="tx1"/>
-                </a:solidFill>
-                <a:latin typeface="+mn-lt"/>
-                <a:ea typeface="+mn-ea"/>
-                <a:cs typeface="+mn-cs"/>
-              </a:defRPr>
-            </a:lvl8pPr>
-            <a:lvl9pPr marL="3657600" algn="l" defTabSz="914400" rtl="0" eaLnBrk="1" latinLnBrk="0" hangingPunct="1">
-              <a:defRPr sz="1800" kern="1200">
-                <a:solidFill>
-                  <a:schemeClr val="tx1"/>
-                </a:solidFill>
-                <a:latin typeface="+mn-lt"/>
-                <a:ea typeface="+mn-ea"/>
-                <a:cs typeface="+mn-cs"/>
-              </a:defRPr>
-            </a:lvl9pPr>
-          </a:lstStyle>
-          <a:p>
-            <a:r>
-              <a:rPr lang="it-IT" sz="2000" noProof="0" dirty="0">
+          <a:bodyPr/>
+          <a:lstStyle/>
+          <a:p>
+            <a:r>
+              <a:rPr lang="it-IT" sz="2000" b="1" dirty="0">
                 <a:solidFill>
                   <a:schemeClr val="tx1"/>
                 </a:solidFill>
               </a:rPr>
-              <a:t>3/3</a:t>
-            </a:r>
+              <a:t>2</a:t>
+            </a:r>
+            <a:r>
+              <a:rPr lang="it-IT" sz="2000" b="1" noProof="0" dirty="0">
+                <a:solidFill>
+                  <a:schemeClr val="tx1"/>
+                </a:solidFill>
+              </a:rPr>
+              <a:t>/2</a:t>
+            </a:r>
+          </a:p>
+        </p:txBody>
+      </p:sp>
+      <p:sp>
+        <p:nvSpPr>
+          <p:cNvPr id="12" name="CasellaDiTesto 11">
+            <a:extLst>
+              <a:ext uri="{FF2B5EF4-FFF2-40B4-BE49-F238E27FC236}">
+                <a16:creationId xmlns:a16="http://schemas.microsoft.com/office/drawing/2014/main" id="{B47C7EF8-7FBE-A0E3-3579-35EA1E5BCF90}"/>
+              </a:ext>
+            </a:extLst>
+          </p:cNvPr>
+          <p:cNvSpPr txBox="1"/>
+          <p:nvPr/>
+        </p:nvSpPr>
+        <p:spPr>
+          <a:xfrm>
+            <a:off x="7893424" y="9745662"/>
+            <a:ext cx="9323294" cy="369332"/>
+          </a:xfrm>
+          <a:prstGeom prst="rect">
+            <a:avLst/>
+          </a:prstGeom>
+          <a:noFill/>
+        </p:spPr>
+        <p:txBody>
+          <a:bodyPr wrap="square">
+            <a:spAutoFit/>
+          </a:bodyPr>
+          <a:lstStyle/>
+          <a:p>
+            <a:r>
+              <a:rPr lang="en-AU" b="1" dirty="0"/>
+              <a:t>25/03/2026</a:t>
+            </a:r>
+            <a:endParaRPr lang="it-IT" dirty="0"/>
           </a:p>
         </p:txBody>
       </p:sp>

</xml_diff>